<commit_message>
docs: refresh suite for 31-check demo, live College Scorecard COA + authoritative 2026-27 Pell, step-two workflows (verify_documents/professional judgment); fold no-space-path, cmd.exe detached-launch, and stop-orphaned-sign-off-executions lessons into the SA runbook + maintenance
</commit_message>
<xml_diff>
--- a/docs/Financial-Aid-AgentCore-Customer.pptx
+++ b/docs/Financial-Aid-AgentCore-Customer.pptx
@@ -2424,7 +2424,7 @@
                 <a:ea typeface="Calibri" pitchFamily="34" charset="-122"/>
                 <a:cs typeface="Calibri" pitchFamily="34" charset="-120"/>
               </a:rPr>
-              <a:t>Walk your financial-aid, privacy, and security teams through the architecture and the live 21-check proof.</a:t>
+              <a:t>Walk your financial-aid, privacy, and security teams through the architecture and the live 31-check proof.</a:t>
             </a:r>
             <a:endParaRPr lang="en-US" sz="1230" dirty="0"/>
           </a:p>
@@ -8946,7 +8946,7 @@
                 <a:ea typeface="Cambria" pitchFamily="34" charset="-122"/>
                 <a:cs typeface="Cambria" pitchFamily="34" charset="-120"/>
               </a:rPr>
-              <a:t>21/21</a:t>
+              <a:t>31/31</a:t>
             </a:r>
             <a:endParaRPr lang="en-US" sz="3000" dirty="0"/>
           </a:p>

</xml_diff>

<commit_message>
fix(sign-off) + docs: request_signoff takes validated access_token (P0-5 parity); correct live count to 32/32
EDU manifest still required 'requester'; live ENFORCE demo failed until fixed, now passes 32/32.
Updated decks/guides/README to the verified 32/32 and regenerated the .pptx/.docx.
</commit_message>
<xml_diff>
--- a/docs/Financial-Aid-AgentCore-Customer.pptx
+++ b/docs/Financial-Aid-AgentCore-Customer.pptx
@@ -2424,7 +2424,7 @@
                 <a:ea typeface="Calibri" pitchFamily="34" charset="-122"/>
                 <a:cs typeface="Calibri" pitchFamily="34" charset="-120"/>
               </a:rPr>
-              <a:t>Walk your financial-aid, privacy, and security teams through the architecture and the live 31-check proof.</a:t>
+              <a:t>Walk your financial-aid, privacy, and security teams through the architecture and the live 32-check proof.</a:t>
             </a:r>
             <a:endParaRPr lang="en-US" sz="1230" dirty="0"/>
           </a:p>
@@ -8946,7 +8946,7 @@
                 <a:ea typeface="Cambria" pitchFamily="34" charset="-122"/>
                 <a:cs typeface="Cambria" pitchFamily="34" charset="-120"/>
               </a:rPr>
-              <a:t>31/31</a:t>
+              <a:t>32/32</a:t>
             </a:r>
             <a:endParaRPr lang="en-US" sz="3000" dirty="0"/>
           </a:p>

</xml_diff>

<commit_message>
EP2 docs+GTM refresh to EP1-captured state
VALIDATED_RELEASE: EP1 fields flipped to captured (validation date, evidence link, full run table - posture/happy-path/VerificationHold/load/storm/canary/defect/teardown). README: new 'Validated evidence (EP1 live run)' section + honest not-yet-done list. GATE-B-CHECKLIST: B1-B6 rows -> EP1 live-proven, run header CAPTURED. GTM: customer+leadership deck stats/notes rebuilt on EP1 (137 tests, 10/10 concurrent, 0 PII hits, VerificationHold), regulatory doc evidence rows updated, 32-check references retired; decks+regulatory.docx regenerated. Suite 137/137.
</commit_message>
<xml_diff>
--- a/docs/Financial-Aid-AgentCore-Customer.pptx
+++ b/docs/Financial-Aid-AgentCore-Customer.pptx
@@ -2424,7 +2424,7 @@
                 <a:ea typeface="Calibri" pitchFamily="34" charset="-122"/>
                 <a:cs typeface="Calibri" pitchFamily="34" charset="-120"/>
               </a:rPr>
-              <a:t>Walk your financial-aid, privacy, and security teams through the architecture and the live 32-check proof.</a:t>
+              <a:t>Walk your financial-aid, privacy, and security teams through the architecture and the captured live validation evidence.</a:t>
             </a:r>
             <a:endParaRPr lang="en-US" sz="1230" dirty="0"/>
           </a:p>
@@ -8946,7 +8946,7 @@
                 <a:ea typeface="Cambria" pitchFamily="34" charset="-122"/>
                 <a:cs typeface="Cambria" pitchFamily="34" charset="-120"/>
               </a:rPr>
-              <a:t>32/32</a:t>
+              <a:t>137/137</a:t>
             </a:r>
             <a:endParaRPr lang="en-US" sz="3000" dirty="0"/>
           </a:p>
@@ -8988,7 +8988,7 @@
                 <a:ea typeface="Calibri" pitchFamily="34" charset="-122"/>
                 <a:cs typeface="Calibri" pitchFamily="34" charset="-120"/>
               </a:rPr>
-              <a:t>governance checks pass, live</a:t>
+              <a:t>automated tests green in CI</a:t>
             </a:r>
             <a:endParaRPr lang="en-US" sz="1150" dirty="0"/>
           </a:p>
@@ -9061,7 +9061,7 @@
                 <a:ea typeface="Cambria" pitchFamily="34" charset="-122"/>
                 <a:cs typeface="Cambria" pitchFamily="34" charset="-120"/>
               </a:rPr>
-              <a:t>Pell+SAP</a:t>
+              <a:t>End-to-end</a:t>
             </a:r>
             <a:endParaRPr lang="en-US" sz="3000" dirty="0"/>
           </a:p>
@@ -9103,7 +9103,7 @@
                 <a:ea typeface="Calibri" pitchFamily="34" charset="-122"/>
                 <a:cs typeface="Calibri" pitchFamily="34" charset="-120"/>
               </a:rPr>
-              <a:t>computed deterministically</a:t>
+              <a:t>proven live - inside a locked-down private network</a:t>
             </a:r>
             <a:endParaRPr lang="en-US" sz="1150" dirty="0"/>
           </a:p>
@@ -9218,7 +9218,7 @@
                 <a:ea typeface="Calibri" pitchFamily="34" charset="-122"/>
                 <a:cs typeface="Calibri" pitchFamily="34" charset="-120"/>
               </a:rPr>
-              <a:t>of awards gated by an aid officer</a:t>
+              <a:t>of determinations gated by an aid officer</a:t>
             </a:r>
             <a:endParaRPr lang="en-US" sz="1150" dirty="0"/>
           </a:p>

</xml_diff>